<commit_message>
Add federated learning, Colab notebooks, packaging and refreshed submission deck
- FedAvg across five bases incl. a data-poor Leh detachment (C-MAPSS);
  results in the benchmark, evaluation doc and Models page
- Colab notebooks: 1D-CNN + Transformer quantile RUL with conformal
  calibration, and federated FedAvg/FedProx with Flower deployment notes
- Makefile, offline Dockerfile and docker-compose, demo video script
- README with results, run instructions and honesty notes
- Deck slides 4-5 updated with measured prototype results and screenshots

Co-Authored-By: Claude Opus 5.5 <noreply@anthropic.com>
Claude-Session: https://claude.ai/code/session_01DjsuzUVdoh8SrCNsHTZmT9
</commit_message>
<xml_diff>
--- a/docs/sih-ppt/TATPAR_SIH26249_Idea.pptx
+++ b/docs/sih-ppt/TATPAR_SIH26249_Idea.pptx
@@ -112,32 +112,32 @@
   <p:extLst>
     <p:ext uri="{521415D9-36F7-43E2-AB2F-B90AF26B5E84}">
       <p14:sectionLst xmlns:p14="http://schemas.microsoft.com/office/powerpoint/2010/main">
-        <p14:section name="Title" id="{dd8d36d7-02c8-15bc-f54e-1ed3b02be2d8}">
+        <p14:section name="Title" id="{df94ee4a-32a4-d1f5-d0ab-705beb095b15}">
           <p14:sldIdLst>
             <p14:sldId id="256"/>
           </p14:sldIdLst>
         </p14:section>
-        <p14:section name="Solution" id="{1749f85d-53b6-eb28-8d05-6ea66c571e24}">
+        <p14:section name="Solution" id="{85dacdcb-feb7-a313-2bd0-974fbe3bcdd3}">
           <p14:sldIdLst>
             <p14:sldId id="257"/>
           </p14:sldIdLst>
         </p14:section>
-        <p14:section name="Approach" id="{e5eda7ee-d79a-7bb1-c6ae-54841d22b011}">
+        <p14:section name="Approach" id="{b134f335-ca55-52ea-dbe9-20a28e4048a3}">
           <p14:sldIdLst>
             <p14:sldId id="258"/>
           </p14:sldIdLst>
         </p14:section>
-        <p14:section name="Feasibility" id="{895c6d73-a13e-e557-36c9-41d6cd1805a7}">
+        <p14:section name="Feasibility" id="{6bbd1751-37ef-0593-4cb8-8ae7dcb9c80c}">
           <p14:sldIdLst>
             <p14:sldId id="259"/>
           </p14:sldIdLst>
         </p14:section>
-        <p14:section name="Impact" id="{35242fb5-e6e1-012c-ea84-f0d7a192c2b3}">
+        <p14:section name="Impact" id="{c308d545-47ea-c54b-3760-d8e6bdc14a42}">
           <p14:sldIdLst>
             <p14:sldId id="260"/>
           </p14:sldIdLst>
         </p14:section>
-        <p14:section name="References" id="{81f1bdc8-01fc-bcd6-a6a5-954384171b87}">
+        <p14:section name="References" id="{887950e2-d65d-d0fc-3451-7d475ba495ca}">
           <p14:sldIdLst>
             <p14:sldId id="261"/>
           </p14:sldIdLst>
@@ -898,7 +898,7 @@
           <a:p>
             <a:r>
               <a:rPr lang="en-US" dirty="0"/>
-              <a:t>Context figures are from open sources (see references). The +1 point arithmetic is illustrative: 1 % of ~550 fighters.</a:t>
+              <a:t>The first two figures are from open sources (see references). The third is measured in the TATPAR prototype on a notional fleet: +20.3 ± 0.5 points over one year, 24 hidden-truth futures.</a:t>
             </a:r>
             <a:endParaRPr lang="en-US" dirty="0"/>
           </a:p>
@@ -4058,11 +4058,11 @@
         <p:spPr>
           <a:xfrm>
             <a:off x="457200" y="1188720"/>
-            <a:ext cx="3566160" cy="1481328"/>
+            <a:ext cx="3566160" cy="1572768"/>
           </a:xfrm>
           <a:prstGeom prst="roundRect">
             <a:avLst>
-              <a:gd name="adj" fmla="val 7407"/>
+              <a:gd name="adj" fmla="val 6977"/>
             </a:avLst>
           </a:prstGeom>
           <a:solidFill>
@@ -4103,10 +4103,10 @@
             <a:r>
               <a:rPr lang="en-US" sz="3600" b="1" dirty="0">
                 <a:solidFill>
-                  <a:schemeClr val="accent1"/>
-                </a:solidFill>
-              </a:rPr>
-              <a:t>100 %</a:t>
+                  <a:schemeClr val="accent2"/>
+                </a:solidFill>
+              </a:rPr>
+              <a:t>+20 pts</a:t>
             </a:r>
             <a:endParaRPr lang="en-US" sz="3600" dirty="0"/>
           </a:p>
@@ -4121,7 +4121,7 @@
         <p:spPr>
           <a:xfrm>
             <a:off x="685800" y="1938528"/>
-            <a:ext cx="3154680" cy="640080"/>
+            <a:ext cx="3154680" cy="749808"/>
           </a:xfrm>
           <a:prstGeom prst="rect">
             <a:avLst/>
@@ -4142,7 +4142,7 @@
                   <a:schemeClr val="tx2"/>
                 </a:solidFill>
               </a:rPr>
-              <a:t>public + synthetic data — no classified inputs needed to build or demo</a:t>
+              <a:t>mission-capable in the working prototype’s Fleet Twin: 57.7 → 78.0 %, same fleet and spares budget (notional data)</a:t>
             </a:r>
             <a:endParaRPr lang="en-US" sz="1300" dirty="0"/>
           </a:p>
@@ -4156,12 +4156,12 @@
         </p:nvSpPr>
         <p:spPr>
           <a:xfrm>
-            <a:off x="457200" y="2807208"/>
-            <a:ext cx="3566160" cy="1481328"/>
+            <a:off x="457200" y="2871216"/>
+            <a:ext cx="3566160" cy="1572768"/>
           </a:xfrm>
           <a:prstGeom prst="roundRect">
             <a:avLst>
-              <a:gd name="adj" fmla="val 7407"/>
+              <a:gd name="adj" fmla="val 6977"/>
             </a:avLst>
           </a:prstGeom>
           <a:solidFill>
@@ -4183,7 +4183,7 @@
         </p:nvSpPr>
         <p:spPr>
           <a:xfrm>
-            <a:off x="685800" y="2916936"/>
+            <a:off x="685800" y="2980944"/>
             <a:ext cx="3108960" cy="640080"/>
           </a:xfrm>
           <a:prstGeom prst="rect">
@@ -4205,7 +4205,7 @@
                   <a:schemeClr val="accent1"/>
                 </a:solidFill>
               </a:rPr>
-              <a:t>0</a:t>
+              <a:t>90 %</a:t>
             </a:r>
             <a:endParaRPr lang="en-US" sz="3600" dirty="0"/>
           </a:p>
@@ -4219,8 +4219,8 @@
         </p:nvSpPr>
         <p:spPr>
           <a:xfrm>
-            <a:off x="685800" y="3557016"/>
-            <a:ext cx="3154680" cy="640080"/>
+            <a:off x="685800" y="3621024"/>
+            <a:ext cx="3154680" cy="749808"/>
           </a:xfrm>
           <a:prstGeom prst="rect">
             <a:avLst/>
@@ -4241,7 +4241,7 @@
                   <a:schemeClr val="tx2"/>
                 </a:solidFill>
               </a:rPr>
-              <a:t>cloud dependencies at runtime — runs air-gapped on a CPU laptop or edge server</a:t>
+              <a:t>calibrated engine-RUL interval coverage on NASA C-MAPSS test sets (82.7 % before conformal calibration)</a:t>
             </a:r>
             <a:endParaRPr lang="en-US" sz="1300" dirty="0"/>
           </a:p>
@@ -4255,12 +4255,12 @@
         </p:nvSpPr>
         <p:spPr>
           <a:xfrm>
-            <a:off x="457200" y="4425696"/>
-            <a:ext cx="3566160" cy="1481328"/>
+            <a:off x="457200" y="4553712"/>
+            <a:ext cx="3566160" cy="1572768"/>
           </a:xfrm>
           <a:prstGeom prst="roundRect">
             <a:avLst>
-              <a:gd name="adj" fmla="val 7407"/>
+              <a:gd name="adj" fmla="val 6977"/>
             </a:avLst>
           </a:prstGeom>
           <a:solidFill>
@@ -4282,7 +4282,7 @@
         </p:nvSpPr>
         <p:spPr>
           <a:xfrm>
-            <a:off x="685800" y="4535424"/>
+            <a:off x="685800" y="4663440"/>
             <a:ext cx="3108960" cy="640080"/>
           </a:xfrm>
           <a:prstGeom prst="rect">
@@ -4301,10 +4301,10 @@
             <a:r>
               <a:rPr lang="en-US" sz="3600" b="1" dirty="0">
                 <a:solidFill>
-                  <a:schemeClr val="accent2"/>
-                </a:solidFill>
-              </a:rPr>
-              <a:t>Proven</a:t>
+                  <a:schemeClr val="accent1"/>
+                </a:solidFill>
+              </a:rPr>
+              <a:t>0</a:t>
             </a:r>
             <a:endParaRPr lang="en-US" sz="3600" dirty="0"/>
           </a:p>
@@ -4318,8 +4318,8 @@
         </p:nvSpPr>
         <p:spPr>
           <a:xfrm>
-            <a:off x="685800" y="5175504"/>
-            <a:ext cx="3154680" cy="640080"/>
+            <a:off x="685800" y="5303520"/>
+            <a:ext cx="3154680" cy="749808"/>
           </a:xfrm>
           <a:prstGeom prst="rect">
             <a:avLst/>
@@ -4340,7 +4340,7 @@
                   <a:schemeClr val="tx2"/>
                 </a:solidFill>
               </a:rPr>
-              <a:t>methods from published air-force research (Hellenic, French, Finnish FMP; USAF sparing)</a:t>
+              <a:t>cloud dependencies — runs air-gapped on a CPU laptop or edge server; public + synthetic data only</a:t>
             </a:r>
             <a:endParaRPr lang="en-US" sz="1300" dirty="0"/>
           </a:p>
@@ -4369,10 +4369,10 @@
             <a:tbl>
               <a:tblPr/>
               <a:tblGrid>
-                <a:gridCol w="2514600"/>
-                <a:gridCol w="4919472"/>
+                <a:gridCol w="2377440"/>
+                <a:gridCol w="5056632"/>
               </a:tblGrid>
-              <a:tr h="548640">
+              <a:tr h="402336">
                 <a:tc>
                   <a:txBody>
                     <a:bodyPr/>
@@ -4382,7 +4382,7 @@
                         <a:buNone/>
                       </a:pPr>
                       <a:r>
-                        <a:rPr lang="en-US" sz="1400" b="1" dirty="0">
+                        <a:rPr lang="en-US" sz="1300" b="1" dirty="0">
                           <a:solidFill>
                             <a:srgbClr val="FFFFFF"/>
                           </a:solidFill>
@@ -4392,14 +4392,14 @@
                         </a:rPr>
                         <a:t>Challenge / risk</a:t>
                       </a:r>
-                      <a:endParaRPr lang="en-US" sz="1400" dirty="0">
+                      <a:endParaRPr lang="en-US" sz="1300" dirty="0">
                         <a:latin typeface="Calibri" charset="0"/>
                         <a:ea typeface="Calibri" charset="0"/>
                         <a:cs typeface="Calibri" charset="0"/>
                       </a:endParaRPr>
                     </a:p>
                   </a:txBody>
-                  <a:tcPr marL="73152" marR="73152" marT="73152" marB="73152" anchor="ctr">
+                  <a:tcPr marL="54864" marR="54864" marT="54864" marB="54864" anchor="ctr">
                     <a:lnL w="6350" cap="flat" cmpd="sng" algn="ctr">
                       <a:solidFill>
                         <a:srgbClr val="D5DEE8"/>
@@ -4450,7 +4450,7 @@
                         <a:buNone/>
                       </a:pPr>
                       <a:r>
-                        <a:rPr lang="en-US" sz="1400" b="1" dirty="0">
+                        <a:rPr lang="en-US" sz="1300" b="1" dirty="0">
                           <a:solidFill>
                             <a:srgbClr val="FFFFFF"/>
                           </a:solidFill>
@@ -4460,14 +4460,14 @@
                         </a:rPr>
                         <a:t>Mitigation built into TATPAR</a:t>
                       </a:r>
-                      <a:endParaRPr lang="en-US" sz="1400" dirty="0">
+                      <a:endParaRPr lang="en-US" sz="1300" dirty="0">
                         <a:latin typeface="Calibri" charset="0"/>
                         <a:ea typeface="Calibri" charset="0"/>
                         <a:cs typeface="Calibri" charset="0"/>
                       </a:endParaRPr>
                     </a:p>
                   </a:txBody>
-                  <a:tcPr marL="73152" marR="73152" marT="73152" marB="73152" anchor="ctr">
+                  <a:tcPr marL="54864" marR="54864" marT="54864" marB="54864" anchor="ctr">
                     <a:lnL w="6350" cap="flat" cmpd="sng" algn="ctr">
                       <a:solidFill>
                         <a:srgbClr val="D5DEE8"/>
@@ -4510,7 +4510,7 @@
                   </a:tcPr>
                 </a:tc>
               </a:tr>
-              <a:tr h="548640">
+              <a:tr h="402336">
                 <a:tc>
                   <a:txBody>
                     <a:bodyPr/>
@@ -4520,7 +4520,7 @@
                         <a:buNone/>
                       </a:pPr>
                       <a:r>
-                        <a:rPr lang="en-US" sz="1300" b="1" dirty="0">
+                        <a:rPr lang="en-US" sz="1200" b="1" dirty="0">
                           <a:solidFill>
                             <a:srgbClr val="0B1B33"/>
                           </a:solidFill>
@@ -4530,14 +4530,14 @@
                         </a:rPr>
                         <a:t>No access to real IAF data</a:t>
                       </a:r>
-                      <a:endParaRPr lang="en-US" sz="1300" dirty="0">
+                      <a:endParaRPr lang="en-US" sz="1200" dirty="0">
                         <a:latin typeface="Calibri" charset="0"/>
                         <a:ea typeface="Calibri" charset="0"/>
                         <a:cs typeface="Calibri" charset="0"/>
                       </a:endParaRPr>
                     </a:p>
                   </a:txBody>
-                  <a:tcPr marL="73152" marR="73152" marT="73152" marB="73152" anchor="ctr">
+                  <a:tcPr marL="54864" marR="54864" marT="54864" marB="54864" anchor="ctr">
                     <a:lnL w="6350" cap="flat" cmpd="sng" algn="ctr">
                       <a:solidFill>
                         <a:srgbClr val="D5DEE8"/>
@@ -4588,7 +4588,7 @@
                         <a:buNone/>
                       </a:pPr>
                       <a:r>
-                        <a:rPr lang="en-US" sz="1300" dirty="0">
+                        <a:rPr lang="en-US" sz="1200" dirty="0">
                           <a:solidFill>
                             <a:srgbClr val="1E3A5F"/>
                           </a:solidFill>
@@ -4598,14 +4598,14 @@
                         </a:rPr>
                         <a:t>Public datasets + synthetic fleet with hidden ground truth; adapters for IMMOLS / e-MMS exports</a:t>
                       </a:r>
-                      <a:endParaRPr lang="en-US" sz="1300" dirty="0">
+                      <a:endParaRPr lang="en-US" sz="1200" dirty="0">
                         <a:latin typeface="Calibri" charset="0"/>
                         <a:ea typeface="Calibri" charset="0"/>
                         <a:cs typeface="Calibri" charset="0"/>
                       </a:endParaRPr>
                     </a:p>
                   </a:txBody>
-                  <a:tcPr marL="73152" marR="73152" marT="73152" marB="73152" anchor="ctr">
+                  <a:tcPr marL="54864" marR="54864" marT="54864" marB="54864" anchor="ctr">
                     <a:lnL w="6350" cap="flat" cmpd="sng" algn="ctr">
                       <a:solidFill>
                         <a:srgbClr val="D5DEE8"/>
@@ -4648,7 +4648,7 @@
                   </a:tcPr>
                 </a:tc>
               </a:tr>
-              <a:tr h="548640">
+              <a:tr h="402336">
                 <a:tc>
                   <a:txBody>
                     <a:bodyPr/>
@@ -4658,7 +4658,7 @@
                         <a:buNone/>
                       </a:pPr>
                       <a:r>
-                        <a:rPr lang="en-US" sz="1300" b="1" dirty="0">
+                        <a:rPr lang="en-US" sz="1200" b="1" dirty="0">
                           <a:solidFill>
                             <a:srgbClr val="0B1B33"/>
                           </a:solidFill>
@@ -4668,14 +4668,14 @@
                         </a:rPr>
                         <a:t>Trust in AI recommendations</a:t>
                       </a:r>
-                      <a:endParaRPr lang="en-US" sz="1300" dirty="0">
+                      <a:endParaRPr lang="en-US" sz="1200" dirty="0">
                         <a:latin typeface="Calibri" charset="0"/>
                         <a:ea typeface="Calibri" charset="0"/>
                         <a:cs typeface="Calibri" charset="0"/>
                       </a:endParaRPr>
                     </a:p>
                   </a:txBody>
-                  <a:tcPr marL="73152" marR="73152" marT="73152" marB="73152" anchor="ctr">
+                  <a:tcPr marL="54864" marR="54864" marT="54864" marB="54864" anchor="ctr">
                     <a:lnL w="6350" cap="flat" cmpd="sng" algn="ctr">
                       <a:solidFill>
                         <a:srgbClr val="D5DEE8"/>
@@ -4726,7 +4726,7 @@
                         <a:buNone/>
                       </a:pPr>
                       <a:r>
-                        <a:rPr lang="en-US" sz="1300" dirty="0">
+                        <a:rPr lang="en-US" sz="1200" dirty="0">
                           <a:solidFill>
                             <a:srgbClr val="1E3A5F"/>
                           </a:solidFill>
@@ -4736,14 +4736,14 @@
                         </a:rPr>
                         <a:t>Calibrated intervals, explanations, human approval, hash-chained audit log</a:t>
                       </a:r>
-                      <a:endParaRPr lang="en-US" sz="1300" dirty="0">
+                      <a:endParaRPr lang="en-US" sz="1200" dirty="0">
                         <a:latin typeface="Calibri" charset="0"/>
                         <a:ea typeface="Calibri" charset="0"/>
                         <a:cs typeface="Calibri" charset="0"/>
                       </a:endParaRPr>
                     </a:p>
                   </a:txBody>
-                  <a:tcPr marL="73152" marR="73152" marT="73152" marB="73152" anchor="ctr">
+                  <a:tcPr marL="54864" marR="54864" marT="54864" marB="54864" anchor="ctr">
                     <a:lnL w="6350" cap="flat" cmpd="sng" algn="ctr">
                       <a:solidFill>
                         <a:srgbClr val="D5DEE8"/>
@@ -4786,7 +4786,7 @@
                   </a:tcPr>
                 </a:tc>
               </a:tr>
-              <a:tr h="548640">
+              <a:tr h="402336">
                 <a:tc>
                   <a:txBody>
                     <a:bodyPr/>
@@ -4796,7 +4796,7 @@
                         <a:buNone/>
                       </a:pPr>
                       <a:r>
-                        <a:rPr lang="en-US" sz="1300" b="1" dirty="0">
+                        <a:rPr lang="en-US" sz="1200" b="1" dirty="0">
                           <a:solidFill>
                             <a:srgbClr val="0B1B33"/>
                           </a:solidFill>
@@ -4806,14 +4806,14 @@
                         </a:rPr>
                         <a:t>Classified, air-gapped networks</a:t>
                       </a:r>
-                      <a:endParaRPr lang="en-US" sz="1300" dirty="0">
+                      <a:endParaRPr lang="en-US" sz="1200" dirty="0">
                         <a:latin typeface="Calibri" charset="0"/>
                         <a:ea typeface="Calibri" charset="0"/>
                         <a:cs typeface="Calibri" charset="0"/>
                       </a:endParaRPr>
                     </a:p>
                   </a:txBody>
-                  <a:tcPr marL="73152" marR="73152" marT="73152" marB="73152" anchor="ctr">
+                  <a:tcPr marL="54864" marR="54864" marT="54864" marB="54864" anchor="ctr">
                     <a:lnL w="6350" cap="flat" cmpd="sng" algn="ctr">
                       <a:solidFill>
                         <a:srgbClr val="D5DEE8"/>
@@ -4864,7 +4864,7 @@
                         <a:buNone/>
                       </a:pPr>
                       <a:r>
-                        <a:rPr lang="en-US" sz="1300" dirty="0">
+                        <a:rPr lang="en-US" sz="1200" dirty="0">
                           <a:solidFill>
                             <a:srgbClr val="1E3A5F"/>
                           </a:solidFill>
@@ -4874,14 +4874,14 @@
                         </a:rPr>
                         <a:t>Fully offline; federated learning shares only model weights</a:t>
                       </a:r>
-                      <a:endParaRPr lang="en-US" sz="1300" dirty="0">
+                      <a:endParaRPr lang="en-US" sz="1200" dirty="0">
                         <a:latin typeface="Calibri" charset="0"/>
                         <a:ea typeface="Calibri" charset="0"/>
                         <a:cs typeface="Calibri" charset="0"/>
                       </a:endParaRPr>
                     </a:p>
                   </a:txBody>
-                  <a:tcPr marL="73152" marR="73152" marT="73152" marB="73152" anchor="ctr">
+                  <a:tcPr marL="54864" marR="54864" marT="54864" marB="54864" anchor="ctr">
                     <a:lnL w="6350" cap="flat" cmpd="sng" algn="ctr">
                       <a:solidFill>
                         <a:srgbClr val="D5DEE8"/>
@@ -4924,7 +4924,7 @@
                   </a:tcPr>
                 </a:tc>
               </a:tr>
-              <a:tr h="548640">
+              <a:tr h="402336">
                 <a:tc>
                   <a:txBody>
                     <a:bodyPr/>
@@ -4934,7 +4934,7 @@
                         <a:buNone/>
                       </a:pPr>
                       <a:r>
-                        <a:rPr lang="en-US" sz="1300" b="1" dirty="0">
+                        <a:rPr lang="en-US" sz="1200" b="1" dirty="0">
                           <a:solidFill>
                             <a:srgbClr val="0B1B33"/>
                           </a:solidFill>
@@ -4944,14 +4944,14 @@
                         </a:rPr>
                         <a:t>Legacy and paper records</a:t>
                       </a:r>
-                      <a:endParaRPr lang="en-US" sz="1300" dirty="0">
+                      <a:endParaRPr lang="en-US" sz="1200" dirty="0">
                         <a:latin typeface="Calibri" charset="0"/>
                         <a:ea typeface="Calibri" charset="0"/>
                         <a:cs typeface="Calibri" charset="0"/>
                       </a:endParaRPr>
                     </a:p>
                   </a:txBody>
-                  <a:tcPr marL="73152" marR="73152" marT="73152" marB="73152" anchor="ctr">
+                  <a:tcPr marL="54864" marR="54864" marT="54864" marB="54864" anchor="ctr">
                     <a:lnL w="6350" cap="flat" cmpd="sng" algn="ctr">
                       <a:solidFill>
                         <a:srgbClr val="D5DEE8"/>
@@ -5002,7 +5002,7 @@
                         <a:buNone/>
                       </a:pPr>
                       <a:r>
-                        <a:rPr lang="en-US" sz="1300" dirty="0">
+                        <a:rPr lang="en-US" sz="1200" dirty="0">
                           <a:solidFill>
                             <a:srgbClr val="1E3A5F"/>
                           </a:solidFill>
@@ -5010,16 +5010,16 @@
                           <a:ea typeface="Calibri" pitchFamily="34" charset="-122"/>
                           <a:cs typeface="Calibri" pitchFamily="34" charset="-120"/>
                         </a:rPr>
-                        <a:t>Common data model (S5000F / ATA), CSV/Excel adapters, data-quality scores</a:t>
+                        <a:t>Common data model (S5000F / ATA), CSV adapters, data-quality scores</a:t>
                       </a:r>
-                      <a:endParaRPr lang="en-US" sz="1300" dirty="0">
+                      <a:endParaRPr lang="en-US" sz="1200" dirty="0">
                         <a:latin typeface="Calibri" charset="0"/>
                         <a:ea typeface="Calibri" charset="0"/>
                         <a:cs typeface="Calibri" charset="0"/>
                       </a:endParaRPr>
                     </a:p>
                   </a:txBody>
-                  <a:tcPr marL="73152" marR="73152" marT="73152" marB="73152" anchor="ctr">
+                  <a:tcPr marL="54864" marR="54864" marT="54864" marB="54864" anchor="ctr">
                     <a:lnL w="6350" cap="flat" cmpd="sng" algn="ctr">
                       <a:solidFill>
                         <a:srgbClr val="D5DEE8"/>
@@ -5062,7 +5062,7 @@
                   </a:tcPr>
                 </a:tc>
               </a:tr>
-              <a:tr h="548640">
+              <a:tr h="402336">
                 <a:tc>
                   <a:txBody>
                     <a:bodyPr/>
@@ -5072,7 +5072,7 @@
                         <a:buNone/>
                       </a:pPr>
                       <a:r>
-                        <a:rPr lang="en-US" sz="1300" b="1" dirty="0">
+                        <a:rPr lang="en-US" sz="1200" b="1" dirty="0">
                           <a:solidFill>
                             <a:srgbClr val="0B1B33"/>
                           </a:solidFill>
@@ -5080,16 +5080,16 @@
                           <a:ea typeface="Calibri" pitchFamily="34" charset="-122"/>
                           <a:cs typeface="Calibri" pitchFamily="34" charset="-120"/>
                         </a:rPr>
-                        <a:t>Optimisation run-time at scale</a:t>
+                        <a:t>Optimisation run-time</a:t>
                       </a:r>
-                      <a:endParaRPr lang="en-US" sz="1300" dirty="0">
+                      <a:endParaRPr lang="en-US" sz="1200" dirty="0">
                         <a:latin typeface="Calibri" charset="0"/>
                         <a:ea typeface="Calibri" charset="0"/>
                         <a:cs typeface="Calibri" charset="0"/>
                       </a:endParaRPr>
                     </a:p>
                   </a:txBody>
-                  <a:tcPr marL="73152" marR="73152" marT="73152" marB="73152" anchor="ctr">
+                  <a:tcPr marL="54864" marR="54864" marT="54864" marB="54864" anchor="ctr">
                     <a:lnL w="6350" cap="flat" cmpd="sng" algn="ctr">
                       <a:solidFill>
                         <a:srgbClr val="D5DEE8"/>
@@ -5140,7 +5140,7 @@
                         <a:buNone/>
                       </a:pPr>
                       <a:r>
-                        <a:rPr lang="en-US" sz="1300" dirty="0">
+                        <a:rPr lang="en-US" sz="1200" dirty="0">
                           <a:solidFill>
                             <a:srgbClr val="1E3A5F"/>
                           </a:solidFill>
@@ -5148,16 +5148,16 @@
                           <a:ea typeface="Calibri" pitchFamily="34" charset="-122"/>
                           <a:cs typeface="Calibri" pitchFamily="34" charset="-120"/>
                         </a:rPr>
-                        <a:t>Rolling horizon, warm start, time-limited CP-SAT, per-squadron decomposition</a:t>
+                        <a:t>CP-SAT plans a squadron in ~1–2 s; rolling horizon, per-squadron decomposition</a:t>
                       </a:r>
-                      <a:endParaRPr lang="en-US" sz="1300" dirty="0">
+                      <a:endParaRPr lang="en-US" sz="1200" dirty="0">
                         <a:latin typeface="Calibri" charset="0"/>
                         <a:ea typeface="Calibri" charset="0"/>
                         <a:cs typeface="Calibri" charset="0"/>
                       </a:endParaRPr>
                     </a:p>
                   </a:txBody>
-                  <a:tcPr marL="73152" marR="73152" marT="73152" marB="73152" anchor="ctr">
+                  <a:tcPr marL="54864" marR="54864" marT="54864" marB="54864" anchor="ctr">
                     <a:lnL w="6350" cap="flat" cmpd="sng" algn="ctr">
                       <a:solidFill>
                         <a:srgbClr val="D5DEE8"/>
@@ -5204,16 +5204,40 @@
           </a:graphicData>
         </a:graphic>
       </p:graphicFrame>
-      <p:sp>
-        <p:nvSpPr>
-          <p:cNvPr id="13" name="path-head"/>
+      <p:pic>
+        <p:nvPicPr>
+          <p:cNvPr id="13" name="shot-0" descr="/home/user/air-power/docs/sih-ppt/shot-planner.png">    </p:cNvPr>
+          <p:cNvPicPr>
+            <a:picLocks noChangeAspect="1"/>
+          </p:cNvPicPr>
+          <p:nvPr/>
+        </p:nvPicPr>
+        <p:blipFill>
+          <a:blip r:embed="rId1"/>
+          <a:stretch>
+            <a:fillRect/>
+          </a:stretch>
+        </p:blipFill>
+        <p:spPr>
+          <a:xfrm>
+            <a:off x="4297680" y="3886200"/>
+            <a:ext cx="2377440" cy="1485900"/>
+          </a:xfrm>
+          <a:prstGeom prst="rect">
+            <a:avLst/>
+          </a:prstGeom>
+        </p:spPr>
+      </p:pic>
+      <p:sp>
+        <p:nvSpPr>
+          <p:cNvPr id="14" name="shot-cap-0"/>
           <p:cNvSpPr txBox="1"/>
           <p:nvPr/>
         </p:nvSpPr>
         <p:spPr>
           <a:xfrm>
-            <a:off x="4297680" y="4846320"/>
-            <a:ext cx="4572000" cy="365760"/>
+            <a:off x="4297680" y="5413248"/>
+            <a:ext cx="2377440" cy="274320"/>
           </a:xfrm>
           <a:prstGeom prst="rect">
             <a:avLst/>
@@ -5229,52 +5253,51 @@
               <a:buNone/>
             </a:pPr>
             <a:r>
-              <a:rPr lang="en-US" sz="1600" b="1" dirty="0">
-                <a:solidFill>
-                  <a:schemeClr val="tx1"/>
-                </a:solidFill>
-              </a:rPr>
-              <a:t>Path to deployment</a:t>
-            </a:r>
-            <a:endParaRPr lang="en-US" sz="1600" dirty="0"/>
-          </a:p>
-        </p:txBody>
-      </p:sp>
-      <p:sp>
-        <p:nvSpPr>
-          <p:cNvPr id="14" name="path-dot-0"/>
-          <p:cNvSpPr/>
-          <p:nvPr/>
-        </p:nvSpPr>
-        <p:spPr>
-          <a:xfrm>
-            <a:off x="4297680" y="5349240"/>
-            <a:ext cx="384048" cy="384048"/>
-          </a:xfrm>
-          <a:prstGeom prst="ellipse">
-            <a:avLst/>
-          </a:prstGeom>
-          <a:solidFill>
-            <a:schemeClr val="accent1"/>
-          </a:solidFill>
-          <a:ln w="12700">
-            <a:solidFill>
-              <a:schemeClr val="accent1"/>
-            </a:solidFill>
-            <a:prstDash val="solid"/>
-          </a:ln>
-        </p:spPr>
-      </p:sp>
-      <p:sp>
-        <p:nvSpPr>
-          <p:cNvPr id="15" name="path-num-0"/>
+              <a:rPr lang="en-US" sz="1100" dirty="0">
+                <a:solidFill>
+                  <a:schemeClr val="accent6"/>
+                </a:solidFill>
+              </a:rPr>
+              <a:t>Readiness planner</a:t>
+            </a:r>
+            <a:endParaRPr lang="en-US" sz="1100" dirty="0"/>
+          </a:p>
+        </p:txBody>
+      </p:sp>
+      <p:pic>
+        <p:nvPicPr>
+          <p:cNvPr id="15" name="shot-1" descr="/home/user/air-power/docs/sih-ppt/shot-flow.png">    </p:cNvPr>
+          <p:cNvPicPr>
+            <a:picLocks noChangeAspect="1"/>
+          </p:cNvPicPr>
+          <p:nvPr/>
+        </p:nvPicPr>
+        <p:blipFill>
+          <a:blip r:embed="rId2"/>
+          <a:stretch>
+            <a:fillRect/>
+          </a:stretch>
+        </p:blipFill>
+        <p:spPr>
+          <a:xfrm>
+            <a:off x="6825996" y="3886200"/>
+            <a:ext cx="2377440" cy="1485900"/>
+          </a:xfrm>
+          <a:prstGeom prst="rect">
+            <a:avLst/>
+          </a:prstGeom>
+        </p:spPr>
+      </p:pic>
+      <p:sp>
+        <p:nvSpPr>
+          <p:cNvPr id="16" name="shot-cap-1"/>
           <p:cNvSpPr txBox="1"/>
           <p:nvPr/>
         </p:nvSpPr>
         <p:spPr>
           <a:xfrm>
-            <a:off x="4297680" y="5349240"/>
-            <a:ext cx="384048" cy="384048"/>
+            <a:off x="6825996" y="5413248"/>
+            <a:ext cx="2377440" cy="274320"/>
           </a:xfrm>
           <a:prstGeom prst="rect">
             <a:avLst/>
@@ -5286,31 +5309,55 @@
           <a:bodyPr wrap="square" lIns="0" tIns="0" rIns="0" bIns="0" rtlCol="0" anchor="ctr"/>
           <a:lstStyle/>
           <a:p>
-            <a:pPr algn="ctr" indent="0" marL="0">
-              <a:buNone/>
-            </a:pPr>
-            <a:r>
-              <a:rPr lang="en-US" sz="1300" b="1" dirty="0">
-                <a:solidFill>
-                  <a:schemeClr val="tx1"/>
-                </a:solidFill>
-              </a:rPr>
-              <a:t>1</a:t>
-            </a:r>
-            <a:endParaRPr lang="en-US" sz="1300" dirty="0"/>
-          </a:p>
-        </p:txBody>
-      </p:sp>
-      <p:sp>
-        <p:nvSpPr>
-          <p:cNvPr id="16" name="path-text-0"/>
+            <a:pPr indent="0" marL="0">
+              <a:buNone/>
+            </a:pPr>
+            <a:r>
+              <a:rPr lang="en-US" sz="1100" dirty="0">
+                <a:solidFill>
+                  <a:schemeClr val="accent6"/>
+                </a:solidFill>
+              </a:rPr>
+              <a:t>CP-SAT flight &amp; maintenance plan</a:t>
+            </a:r>
+            <a:endParaRPr lang="en-US" sz="1100" dirty="0"/>
+          </a:p>
+        </p:txBody>
+      </p:sp>
+      <p:pic>
+        <p:nvPicPr>
+          <p:cNvPr id="17" name="shot-2" descr="/home/user/air-power/docs/sih-ppt/shot-aircraft.png">    </p:cNvPr>
+          <p:cNvPicPr>
+            <a:picLocks noChangeAspect="1"/>
+          </p:cNvPicPr>
+          <p:nvPr/>
+        </p:nvPicPr>
+        <p:blipFill>
+          <a:blip r:embed="rId3"/>
+          <a:stretch>
+            <a:fillRect/>
+          </a:stretch>
+        </p:blipFill>
+        <p:spPr>
+          <a:xfrm>
+            <a:off x="9354312" y="3886200"/>
+            <a:ext cx="2377440" cy="1485900"/>
+          </a:xfrm>
+          <a:prstGeom prst="rect">
+            <a:avLst/>
+          </a:prstGeom>
+        </p:spPr>
+      </p:pic>
+      <p:sp>
+        <p:nvSpPr>
+          <p:cNvPr id="18" name="shot-cap-2"/>
           <p:cNvSpPr txBox="1"/>
           <p:nvPr/>
         </p:nvSpPr>
         <p:spPr>
           <a:xfrm>
-            <a:off x="4754880" y="5198364"/>
-            <a:ext cx="1417320" cy="685800"/>
+            <a:off x="9354312" y="5413248"/>
+            <a:ext cx="2377440" cy="274320"/>
           </a:xfrm>
           <a:prstGeom prst="rect">
             <a:avLst/>
@@ -5326,52 +5373,27 @@
               <a:buNone/>
             </a:pPr>
             <a:r>
-              <a:rPr lang="en-US" sz="1200" dirty="0">
-                <a:solidFill>
-                  <a:schemeClr val="tx2"/>
-                </a:solidFill>
-              </a:rPr>
-              <a:t>SIH prototype</a:t>
-            </a:r>
-            <a:endParaRPr lang="en-US" sz="1200" dirty="0"/>
-          </a:p>
-        </p:txBody>
-      </p:sp>
-      <p:sp>
-        <p:nvSpPr>
-          <p:cNvPr id="17" name="path-dot-1"/>
-          <p:cNvSpPr/>
-          <p:nvPr/>
-        </p:nvSpPr>
-        <p:spPr>
-          <a:xfrm>
-            <a:off x="6199632" y="5349240"/>
-            <a:ext cx="384048" cy="384048"/>
-          </a:xfrm>
-          <a:prstGeom prst="ellipse">
-            <a:avLst/>
-          </a:prstGeom>
-          <a:solidFill>
-            <a:schemeClr val="tx2"/>
-          </a:solidFill>
-          <a:ln w="12700">
-            <a:solidFill>
-              <a:schemeClr val="tx2"/>
-            </a:solidFill>
-            <a:prstDash val="solid"/>
-          </a:ln>
-        </p:spPr>
-      </p:sp>
-      <p:sp>
-        <p:nvSpPr>
-          <p:cNvPr id="18" name="path-num-1"/>
+              <a:rPr lang="en-US" sz="1100" dirty="0">
+                <a:solidFill>
+                  <a:schemeClr val="accent6"/>
+                </a:solidFill>
+              </a:rPr>
+              <a:t>Engine RUL + module attribution</a:t>
+            </a:r>
+            <a:endParaRPr lang="en-US" sz="1100" dirty="0"/>
+          </a:p>
+        </p:txBody>
+      </p:sp>
+      <p:sp>
+        <p:nvSpPr>
+          <p:cNvPr id="19" name="path"/>
           <p:cNvSpPr txBox="1"/>
           <p:nvPr/>
         </p:nvSpPr>
         <p:spPr>
           <a:xfrm>
-            <a:off x="6199632" y="5349240"/>
-            <a:ext cx="384048" cy="384048"/>
+            <a:off x="4297680" y="5760720"/>
+            <a:ext cx="7434072" cy="502920"/>
           </a:xfrm>
           <a:prstGeom prst="rect">
             <a:avLst/>
@@ -5380,45 +5402,20 @@
           <a:ln/>
         </p:spPr>
         <p:txBody>
-          <a:bodyPr wrap="square" lIns="0" tIns="0" rIns="0" bIns="0" rtlCol="0" anchor="ctr"/>
-          <a:lstStyle/>
-          <a:p>
-            <a:pPr algn="ctr" indent="0" marL="0">
-              <a:buNone/>
-            </a:pPr>
-            <a:r>
-              <a:rPr lang="en-US" sz="1300" b="1" dirty="0">
-                <a:solidFill>
-                  <a:schemeClr val="bg1"/>
-                </a:solidFill>
-              </a:rPr>
-              <a:t>2</a:t>
-            </a:r>
-            <a:endParaRPr lang="en-US" sz="1300" dirty="0"/>
-          </a:p>
-        </p:txBody>
-      </p:sp>
-      <p:sp>
-        <p:nvSpPr>
-          <p:cNvPr id="19" name="path-text-1"/>
-          <p:cNvSpPr txBox="1"/>
-          <p:nvPr/>
-        </p:nvSpPr>
-        <p:spPr>
-          <a:xfrm>
-            <a:off x="6656832" y="5198364"/>
-            <a:ext cx="1417320" cy="685800"/>
-          </a:xfrm>
-          <a:prstGeom prst="rect">
-            <a:avLst/>
-          </a:prstGeom>
-          <a:noFill/>
-          <a:ln/>
-        </p:spPr>
-        <p:txBody>
-          <a:bodyPr wrap="square" lIns="0" tIns="0" rIns="0" bIns="0" rtlCol="0" anchor="ctr"/>
-          <a:lstStyle/>
-          <a:p>
+          <a:bodyPr wrap="square" lIns="0" tIns="0" rIns="0" bIns="0" rtlCol="0" anchor="t"/>
+          <a:lstStyle/>
+          <a:p>
+            <a:pPr indent="0" marL="0">
+              <a:buNone/>
+            </a:pPr>
+            <a:r>
+              <a:rPr lang="en-US" sz="1200" b="1" dirty="0">
+                <a:solidFill>
+                  <a:schemeClr val="tx1"/>
+                </a:solidFill>
+              </a:rPr>
+              <a:t>Working prototype built. </a:t>
+            </a:r>
             <a:pPr indent="0" marL="0">
               <a:buNone/>
             </a:pPr>
@@ -5428,201 +5425,7 @@
                   <a:schemeClr val="tx2"/>
                 </a:solidFill>
               </a:rPr>
-              <a:t>Pilot on one squadron’s historical exports</a:t>
-            </a:r>
-            <a:endParaRPr lang="en-US" sz="1200" dirty="0"/>
-          </a:p>
-        </p:txBody>
-      </p:sp>
-      <p:sp>
-        <p:nvSpPr>
-          <p:cNvPr id="20" name="path-dot-2"/>
-          <p:cNvSpPr/>
-          <p:nvPr/>
-        </p:nvSpPr>
-        <p:spPr>
-          <a:xfrm>
-            <a:off x="8101584" y="5349240"/>
-            <a:ext cx="384048" cy="384048"/>
-          </a:xfrm>
-          <a:prstGeom prst="ellipse">
-            <a:avLst/>
-          </a:prstGeom>
-          <a:solidFill>
-            <a:schemeClr val="tx2"/>
-          </a:solidFill>
-          <a:ln w="12700">
-            <a:solidFill>
-              <a:schemeClr val="tx2"/>
-            </a:solidFill>
-            <a:prstDash val="solid"/>
-          </a:ln>
-        </p:spPr>
-      </p:sp>
-      <p:sp>
-        <p:nvSpPr>
-          <p:cNvPr id="21" name="path-num-2"/>
-          <p:cNvSpPr txBox="1"/>
-          <p:nvPr/>
-        </p:nvSpPr>
-        <p:spPr>
-          <a:xfrm>
-            <a:off x="8101584" y="5349240"/>
-            <a:ext cx="384048" cy="384048"/>
-          </a:xfrm>
-          <a:prstGeom prst="rect">
-            <a:avLst/>
-          </a:prstGeom>
-          <a:noFill/>
-          <a:ln/>
-        </p:spPr>
-        <p:txBody>
-          <a:bodyPr wrap="square" lIns="0" tIns="0" rIns="0" bIns="0" rtlCol="0" anchor="ctr"/>
-          <a:lstStyle/>
-          <a:p>
-            <a:pPr algn="ctr" indent="0" marL="0">
-              <a:buNone/>
-            </a:pPr>
-            <a:r>
-              <a:rPr lang="en-US" sz="1300" b="1" dirty="0">
-                <a:solidFill>
-                  <a:schemeClr val="bg1"/>
-                </a:solidFill>
-              </a:rPr>
-              <a:t>3</a:t>
-            </a:r>
-            <a:endParaRPr lang="en-US" sz="1300" dirty="0"/>
-          </a:p>
-        </p:txBody>
-      </p:sp>
-      <p:sp>
-        <p:nvSpPr>
-          <p:cNvPr id="22" name="path-text-2"/>
-          <p:cNvSpPr txBox="1"/>
-          <p:nvPr/>
-        </p:nvSpPr>
-        <p:spPr>
-          <a:xfrm>
-            <a:off x="8558784" y="5198364"/>
-            <a:ext cx="1417320" cy="685800"/>
-          </a:xfrm>
-          <a:prstGeom prst="rect">
-            <a:avLst/>
-          </a:prstGeom>
-          <a:noFill/>
-          <a:ln/>
-        </p:spPr>
-        <p:txBody>
-          <a:bodyPr wrap="square" lIns="0" tIns="0" rIns="0" bIns="0" rtlCol="0" anchor="ctr"/>
-          <a:lstStyle/>
-          <a:p>
-            <a:pPr indent="0" marL="0">
-              <a:buNone/>
-            </a:pPr>
-            <a:r>
-              <a:rPr lang="en-US" sz="1200" dirty="0">
-                <a:solidFill>
-                  <a:schemeClr val="tx2"/>
-                </a:solidFill>
-              </a:rPr>
-              <a:t>BRD + IMMOLS integration</a:t>
-            </a:r>
-            <a:endParaRPr lang="en-US" sz="1200" dirty="0"/>
-          </a:p>
-        </p:txBody>
-      </p:sp>
-      <p:sp>
-        <p:nvSpPr>
-          <p:cNvPr id="23" name="path-dot-3"/>
-          <p:cNvSpPr/>
-          <p:nvPr/>
-        </p:nvSpPr>
-        <p:spPr>
-          <a:xfrm>
-            <a:off x="10003536" y="5349240"/>
-            <a:ext cx="384048" cy="384048"/>
-          </a:xfrm>
-          <a:prstGeom prst="ellipse">
-            <a:avLst/>
-          </a:prstGeom>
-          <a:solidFill>
-            <a:schemeClr val="tx2"/>
-          </a:solidFill>
-          <a:ln w="12700">
-            <a:solidFill>
-              <a:schemeClr val="tx2"/>
-            </a:solidFill>
-            <a:prstDash val="solid"/>
-          </a:ln>
-        </p:spPr>
-      </p:sp>
-      <p:sp>
-        <p:nvSpPr>
-          <p:cNvPr id="24" name="path-num-3"/>
-          <p:cNvSpPr txBox="1"/>
-          <p:nvPr/>
-        </p:nvSpPr>
-        <p:spPr>
-          <a:xfrm>
-            <a:off x="10003536" y="5349240"/>
-            <a:ext cx="384048" cy="384048"/>
-          </a:xfrm>
-          <a:prstGeom prst="rect">
-            <a:avLst/>
-          </a:prstGeom>
-          <a:noFill/>
-          <a:ln/>
-        </p:spPr>
-        <p:txBody>
-          <a:bodyPr wrap="square" lIns="0" tIns="0" rIns="0" bIns="0" rtlCol="0" anchor="ctr"/>
-          <a:lstStyle/>
-          <a:p>
-            <a:pPr algn="ctr" indent="0" marL="0">
-              <a:buNone/>
-            </a:pPr>
-            <a:r>
-              <a:rPr lang="en-US" sz="1300" b="1" dirty="0">
-                <a:solidFill>
-                  <a:schemeClr val="bg1"/>
-                </a:solidFill>
-              </a:rPr>
-              <a:t>4</a:t>
-            </a:r>
-            <a:endParaRPr lang="en-US" sz="1300" dirty="0"/>
-          </a:p>
-        </p:txBody>
-      </p:sp>
-      <p:sp>
-        <p:nvSpPr>
-          <p:cNvPr id="25" name="path-text-3"/>
-          <p:cNvSpPr txBox="1"/>
-          <p:nvPr/>
-        </p:nvSpPr>
-        <p:spPr>
-          <a:xfrm>
-            <a:off x="10460736" y="5198364"/>
-            <a:ext cx="1417320" cy="685800"/>
-          </a:xfrm>
-          <a:prstGeom prst="rect">
-            <a:avLst/>
-          </a:prstGeom>
-          <a:noFill/>
-          <a:ln/>
-        </p:spPr>
-        <p:txBody>
-          <a:bodyPr wrap="square" lIns="0" tIns="0" rIns="0" bIns="0" rtlCol="0" anchor="ctr"/>
-          <a:lstStyle/>
-          <a:p>
-            <a:pPr indent="0" marL="0">
-              <a:buNone/>
-            </a:pPr>
-            <a:r>
-              <a:rPr lang="en-US" sz="1200" dirty="0">
-                <a:solidFill>
-                  <a:schemeClr val="tx2"/>
-                </a:solidFill>
-              </a:rPr>
-              <a:t>Command-wide rollout</a:t>
+              <a:t>Path to deployment: SIH prototype → pilot on one squadron’s historical exports → BRD + IMMOLS integration → command-wide rollout.</a:t>
             </a:r>
             <a:endParaRPr lang="en-US" sz="1200" dirty="0"/>
           </a:p>
@@ -5991,7 +5794,7 @@
                   <a:schemeClr val="accent2"/>
                 </a:solidFill>
               </a:rPr>
-              <a:t>≈ 5–6</a:t>
+              <a:t>≈ 13</a:t>
             </a:r>
             <a:endParaRPr lang="en-US" sz="4000" dirty="0"/>
           </a:p>
@@ -6027,7 +5830,7 @@
                   <a:schemeClr val="tx2"/>
                 </a:solidFill>
               </a:rPr>
-              <a:t>more mission-capable fighters for every +1 point of availability on a ~550-fighter fleet (illustrative)</a:t>
+              <a:t>more aircraft mission-capable every day from a 64-aircraft fleet in the prototype twin — same spares budget (notional data)</a:t>
             </a:r>
             <a:endParaRPr lang="en-US" sz="1300" dirty="0"/>
           </a:p>

</xml_diff>